<commit_message>
feat: H.264 codec priority, adaptive bitrate, low-end mode, Telegram webhook
- H.264 priority in SDP via setCodecPreferences (HW encode on all devices)
- Adaptive bitrate via getStats: loss >5% lowers bitrate, <1% raises (10s loop)
- Low-end device detection (<=4 CPU cores or <=4GB RAM)
  - Camera 480x360@15fps, screen 640x360@10fps
  - Toggle in Settings
- Telegram bot: polling -> webhook (server sleeps when idle, saves ~500h/month)
- Mobile app synced with same codec preference + low-end detection
</commit_message>
<xml_diff>
--- a/docs/обложка для Хабр.pptx
+++ b/docs/обложка для Хабр.pptx
@@ -6,6 +6,7 @@
   </p:sldMasterIdLst>
   <p:sldIdLst>
     <p:sldId id="256" r:id="rId2"/>
+    <p:sldId id="257" r:id="rId3"/>
   </p:sldIdLst>
   <p:sldSz cx="12192000" cy="6858000"/>
   <p:notesSz cx="6858000" cy="9144000"/>
@@ -104,6 +105,11 @@
       </a:defRPr>
     </a:lvl9pPr>
   </p:defaultTextStyle>
+  <p:extLst>
+    <p:ext uri="{EFAFB233-063F-42B5-8137-9DF3F51BA10A}">
+      <p15:sldGuideLst xmlns:p15="http://schemas.microsoft.com/office/powerpoint/2012/main"/>
+    </p:ext>
+  </p:extLst>
 </p:presentation>
 </file>
 
@@ -254,7 +260,7 @@
           <a:p>
             <a:fld id="{699E25F0-10E6-41AC-B6C9-EA35F25A2041}" type="datetimeFigureOut">
               <a:rPr lang="ru-RU" smtClean="0"/>
-              <a:t>10.06.2026</a:t>
+              <a:t>17.06.2026</a:t>
             </a:fld>
             <a:endParaRPr lang="ru-RU"/>
           </a:p>
@@ -452,7 +458,7 @@
           <a:p>
             <a:fld id="{699E25F0-10E6-41AC-B6C9-EA35F25A2041}" type="datetimeFigureOut">
               <a:rPr lang="ru-RU" smtClean="0"/>
-              <a:t>10.06.2026</a:t>
+              <a:t>17.06.2026</a:t>
             </a:fld>
             <a:endParaRPr lang="ru-RU"/>
           </a:p>
@@ -660,7 +666,7 @@
           <a:p>
             <a:fld id="{699E25F0-10E6-41AC-B6C9-EA35F25A2041}" type="datetimeFigureOut">
               <a:rPr lang="ru-RU" smtClean="0"/>
-              <a:t>10.06.2026</a:t>
+              <a:t>17.06.2026</a:t>
             </a:fld>
             <a:endParaRPr lang="ru-RU"/>
           </a:p>
@@ -858,7 +864,7 @@
           <a:p>
             <a:fld id="{699E25F0-10E6-41AC-B6C9-EA35F25A2041}" type="datetimeFigureOut">
               <a:rPr lang="ru-RU" smtClean="0"/>
-              <a:t>10.06.2026</a:t>
+              <a:t>17.06.2026</a:t>
             </a:fld>
             <a:endParaRPr lang="ru-RU"/>
           </a:p>
@@ -1133,7 +1139,7 @@
           <a:p>
             <a:fld id="{699E25F0-10E6-41AC-B6C9-EA35F25A2041}" type="datetimeFigureOut">
               <a:rPr lang="ru-RU" smtClean="0"/>
-              <a:t>10.06.2026</a:t>
+              <a:t>17.06.2026</a:t>
             </a:fld>
             <a:endParaRPr lang="ru-RU"/>
           </a:p>
@@ -1398,7 +1404,7 @@
           <a:p>
             <a:fld id="{699E25F0-10E6-41AC-B6C9-EA35F25A2041}" type="datetimeFigureOut">
               <a:rPr lang="ru-RU" smtClean="0"/>
-              <a:t>10.06.2026</a:t>
+              <a:t>17.06.2026</a:t>
             </a:fld>
             <a:endParaRPr lang="ru-RU"/>
           </a:p>
@@ -1810,7 +1816,7 @@
           <a:p>
             <a:fld id="{699E25F0-10E6-41AC-B6C9-EA35F25A2041}" type="datetimeFigureOut">
               <a:rPr lang="ru-RU" smtClean="0"/>
-              <a:t>10.06.2026</a:t>
+              <a:t>17.06.2026</a:t>
             </a:fld>
             <a:endParaRPr lang="ru-RU"/>
           </a:p>
@@ -1951,7 +1957,7 @@
           <a:p>
             <a:fld id="{699E25F0-10E6-41AC-B6C9-EA35F25A2041}" type="datetimeFigureOut">
               <a:rPr lang="ru-RU" smtClean="0"/>
-              <a:t>10.06.2026</a:t>
+              <a:t>17.06.2026</a:t>
             </a:fld>
             <a:endParaRPr lang="ru-RU"/>
           </a:p>
@@ -2064,7 +2070,7 @@
           <a:p>
             <a:fld id="{699E25F0-10E6-41AC-B6C9-EA35F25A2041}" type="datetimeFigureOut">
               <a:rPr lang="ru-RU" smtClean="0"/>
-              <a:t>10.06.2026</a:t>
+              <a:t>17.06.2026</a:t>
             </a:fld>
             <a:endParaRPr lang="ru-RU"/>
           </a:p>
@@ -2375,7 +2381,7 @@
           <a:p>
             <a:fld id="{699E25F0-10E6-41AC-B6C9-EA35F25A2041}" type="datetimeFigureOut">
               <a:rPr lang="ru-RU" smtClean="0"/>
-              <a:t>10.06.2026</a:t>
+              <a:t>17.06.2026</a:t>
             </a:fld>
             <a:endParaRPr lang="ru-RU"/>
           </a:p>
@@ -2663,7 +2669,7 @@
           <a:p>
             <a:fld id="{699E25F0-10E6-41AC-B6C9-EA35F25A2041}" type="datetimeFigureOut">
               <a:rPr lang="ru-RU" smtClean="0"/>
-              <a:t>10.06.2026</a:t>
+              <a:t>17.06.2026</a:t>
             </a:fld>
             <a:endParaRPr lang="ru-RU"/>
           </a:p>
@@ -2904,7 +2910,7 @@
           <a:p>
             <a:fld id="{699E25F0-10E6-41AC-B6C9-EA35F25A2041}" type="datetimeFigureOut">
               <a:rPr lang="ru-RU" smtClean="0"/>
-              <a:t>10.06.2026</a:t>
+              <a:t>17.06.2026</a:t>
             </a:fld>
             <a:endParaRPr lang="ru-RU"/>
           </a:p>
@@ -3475,6 +3481,357 @@
 </p:sld>
 </file>
 
+<file path=ppt/slides/slide2.xml><?xml version="1.0" encoding="utf-8"?>
+<p:sld xmlns:a="http://schemas.openxmlformats.org/drawingml/2006/main" xmlns:r="http://schemas.openxmlformats.org/officeDocument/2006/relationships" xmlns:p="http://schemas.openxmlformats.org/presentationml/2006/main">
+  <p:cSld>
+    <p:spTree>
+      <p:nvGrpSpPr>
+        <p:cNvPr id="1" name=""/>
+        <p:cNvGrpSpPr/>
+        <p:nvPr/>
+      </p:nvGrpSpPr>
+      <p:grpSpPr>
+        <a:xfrm>
+          <a:off x="0" y="0"/>
+          <a:ext cx="0" cy="0"/>
+          <a:chOff x="0" y="0"/>
+          <a:chExt cx="0" cy="0"/>
+        </a:xfrm>
+      </p:grpSpPr>
+      <p:sp>
+        <p:nvSpPr>
+          <p:cNvPr id="4" name="Прямоугольник 3">
+            <a:extLst>
+              <a:ext uri="{FF2B5EF4-FFF2-40B4-BE49-F238E27FC236}">
+                <a16:creationId xmlns:a16="http://schemas.microsoft.com/office/drawing/2014/main" id="{73CBE10E-B2D1-4C45-AEC6-D143601067C4}"/>
+              </a:ext>
+            </a:extLst>
+          </p:cNvPr>
+          <p:cNvSpPr/>
+          <p:nvPr/>
+        </p:nvSpPr>
+        <p:spPr>
+          <a:xfrm>
+            <a:off x="0" y="0"/>
+            <a:ext cx="12192000" cy="6858000"/>
+          </a:xfrm>
+          <a:prstGeom prst="rect">
+            <a:avLst/>
+          </a:prstGeom>
+          <a:solidFill>
+            <a:srgbClr val="100F14"/>
+          </a:solidFill>
+        </p:spPr>
+        <p:style>
+          <a:lnRef idx="2">
+            <a:schemeClr val="dk1">
+              <a:shade val="50000"/>
+            </a:schemeClr>
+          </a:lnRef>
+          <a:fillRef idx="1">
+            <a:schemeClr val="dk1"/>
+          </a:fillRef>
+          <a:effectRef idx="0">
+            <a:schemeClr val="dk1"/>
+          </a:effectRef>
+          <a:fontRef idx="minor">
+            <a:schemeClr val="lt1"/>
+          </a:fontRef>
+        </p:style>
+        <p:txBody>
+          <a:bodyPr rtlCol="0" anchor="ctr"/>
+          <a:lstStyle/>
+          <a:p>
+            <a:pPr algn="ctr"/>
+            <a:r>
+              <a:rPr lang="ru-RU" b="0" i="0" dirty="0">
+                <a:solidFill>
+                  <a:srgbClr val="171717"/>
+                </a:solidFill>
+                <a:effectLst/>
+                <a:latin typeface="ui-sans-serif"/>
+              </a:rPr>
+              <a:t>Сайт и скачать: </a:t>
+            </a:r>
+            <a:r>
+              <a:rPr lang="en-US" b="0" i="0" dirty="0">
+                <a:solidFill>
+                  <a:srgbClr val="171717"/>
+                </a:solidFill>
+                <a:effectLst/>
+                <a:latin typeface="ui-sans-serif"/>
+              </a:rPr>
+              <a:t>tvhamsters.outmilk.online Telegram-</a:t>
+            </a:r>
+            <a:r>
+              <a:rPr lang="ru-RU" b="0" i="0" dirty="0">
+                <a:solidFill>
+                  <a:srgbClr val="171717"/>
+                </a:solidFill>
+                <a:effectLst/>
+                <a:latin typeface="ui-sans-serif"/>
+              </a:rPr>
+              <a:t>канал: </a:t>
+            </a:r>
+            <a:r>
+              <a:rPr lang="en-US" b="0" i="0" dirty="0">
+                <a:solidFill>
+                  <a:srgbClr val="171717"/>
+                </a:solidFill>
+                <a:effectLst/>
+                <a:latin typeface="ui-sans-serif"/>
+              </a:rPr>
+              <a:t>t.me/tvhamsters </a:t>
+            </a:r>
+            <a:r>
+              <a:rPr lang="ru-RU" b="0" i="0" dirty="0">
+                <a:solidFill>
+                  <a:srgbClr val="171717"/>
+                </a:solidFill>
+                <a:effectLst/>
+                <a:latin typeface="ui-sans-serif"/>
+              </a:rPr>
+              <a:t>Бот для связи: </a:t>
+            </a:r>
+            <a:r>
+              <a:rPr lang="en-US" b="0" i="0" dirty="0">
+                <a:solidFill>
+                  <a:srgbClr val="171717"/>
+                </a:solidFill>
+                <a:effectLst/>
+                <a:latin typeface="ui-sans-serif"/>
+              </a:rPr>
+              <a:t>t.me/</a:t>
+            </a:r>
+            <a:endParaRPr lang="ru-RU" dirty="0">
+              <a:solidFill>
+                <a:schemeClr val="bg1">
+                  <a:lumMod val="65000"/>
+                </a:schemeClr>
+              </a:solidFill>
+            </a:endParaRPr>
+          </a:p>
+        </p:txBody>
+      </p:sp>
+      <p:pic>
+        <p:nvPicPr>
+          <p:cNvPr id="6" name="Рисунок 5">
+            <a:extLst>
+              <a:ext uri="{FF2B5EF4-FFF2-40B4-BE49-F238E27FC236}">
+                <a16:creationId xmlns:a16="http://schemas.microsoft.com/office/drawing/2014/main" id="{C7472A09-381C-48D1-9161-3847EF533FAB}"/>
+              </a:ext>
+            </a:extLst>
+          </p:cNvPr>
+          <p:cNvPicPr>
+            <a:picLocks noChangeAspect="1"/>
+          </p:cNvPicPr>
+          <p:nvPr/>
+        </p:nvPicPr>
+        <p:blipFill>
+          <a:blip r:embed="rId2"/>
+          <a:stretch>
+            <a:fillRect/>
+          </a:stretch>
+        </p:blipFill>
+        <p:spPr>
+          <a:xfrm>
+            <a:off x="3786802" y="161768"/>
+            <a:ext cx="4305234" cy="2696916"/>
+          </a:xfrm>
+          <a:prstGeom prst="rect">
+            <a:avLst/>
+          </a:prstGeom>
+        </p:spPr>
+      </p:pic>
+      <p:pic>
+        <p:nvPicPr>
+          <p:cNvPr id="8" name="Рисунок 7">
+            <a:extLst>
+              <a:ext uri="{FF2B5EF4-FFF2-40B4-BE49-F238E27FC236}">
+                <a16:creationId xmlns:a16="http://schemas.microsoft.com/office/drawing/2014/main" id="{3E630A8C-0F40-425D-8B09-9AA965D5B042}"/>
+              </a:ext>
+            </a:extLst>
+          </p:cNvPr>
+          <p:cNvPicPr>
+            <a:picLocks noChangeAspect="1"/>
+          </p:cNvPicPr>
+          <p:nvPr/>
+        </p:nvPicPr>
+        <p:blipFill>
+          <a:blip r:embed="rId3"/>
+          <a:stretch>
+            <a:fillRect/>
+          </a:stretch>
+        </p:blipFill>
+        <p:spPr>
+          <a:xfrm>
+            <a:off x="2628794" y="2858684"/>
+            <a:ext cx="6934411" cy="2969171"/>
+          </a:xfrm>
+          <a:prstGeom prst="rect">
+            <a:avLst/>
+          </a:prstGeom>
+        </p:spPr>
+      </p:pic>
+      <p:sp>
+        <p:nvSpPr>
+          <p:cNvPr id="9" name="TextBox 8">
+            <a:extLst>
+              <a:ext uri="{FF2B5EF4-FFF2-40B4-BE49-F238E27FC236}">
+                <a16:creationId xmlns:a16="http://schemas.microsoft.com/office/drawing/2014/main" id="{A8A09969-74AD-4D5E-94E8-F02D03325DF9}"/>
+              </a:ext>
+            </a:extLst>
+          </p:cNvPr>
+          <p:cNvSpPr txBox="1"/>
+          <p:nvPr/>
+        </p:nvSpPr>
+        <p:spPr>
+          <a:xfrm>
+            <a:off x="4776280" y="5827855"/>
+            <a:ext cx="2326278" cy="600164"/>
+          </a:xfrm>
+          <a:prstGeom prst="rect">
+            <a:avLst/>
+          </a:prstGeom>
+          <a:noFill/>
+        </p:spPr>
+        <p:txBody>
+          <a:bodyPr wrap="none" rtlCol="0">
+            <a:spAutoFit/>
+          </a:bodyPr>
+          <a:lstStyle/>
+          <a:p>
+            <a:pPr algn="ctr"/>
+            <a:r>
+              <a:rPr lang="ru-RU" sz="1100" b="0" i="0" dirty="0">
+                <a:solidFill>
+                  <a:srgbClr val="775DA0"/>
+                </a:solidFill>
+                <a:effectLst/>
+                <a:latin typeface="ui-sans-serif"/>
+              </a:rPr>
+              <a:t>Сайт</a:t>
+            </a:r>
+            <a:r>
+              <a:rPr lang="ru-RU" sz="1100" b="0" i="0" dirty="0">
+                <a:solidFill>
+                  <a:srgbClr val="AA52DD"/>
+                </a:solidFill>
+                <a:effectLst/>
+                <a:latin typeface="ui-sans-serif"/>
+              </a:rPr>
+              <a:t>: </a:t>
+            </a:r>
+            <a:r>
+              <a:rPr lang="en-US" sz="1100" b="0" i="0" dirty="0">
+                <a:solidFill>
+                  <a:srgbClr val="AA52DD"/>
+                </a:solidFill>
+                <a:effectLst/>
+                <a:latin typeface="ui-sans-serif"/>
+              </a:rPr>
+              <a:t>tvhamsters.outmilk.online</a:t>
+            </a:r>
+            <a:endParaRPr lang="ru-RU" sz="1100" b="0" i="0" dirty="0">
+              <a:solidFill>
+                <a:srgbClr val="AA52DD"/>
+              </a:solidFill>
+              <a:effectLst/>
+              <a:latin typeface="ui-sans-serif"/>
+            </a:endParaRPr>
+          </a:p>
+          <a:p>
+            <a:pPr algn="ctr"/>
+            <a:r>
+              <a:rPr lang="en-US" sz="1100" b="0" i="0" dirty="0">
+                <a:solidFill>
+                  <a:srgbClr val="775DA0"/>
+                </a:solidFill>
+                <a:effectLst/>
+                <a:latin typeface="ui-sans-serif"/>
+              </a:rPr>
+              <a:t>Telegram-</a:t>
+            </a:r>
+            <a:r>
+              <a:rPr lang="ru-RU" sz="1100" b="0" i="0" dirty="0">
+                <a:solidFill>
+                  <a:srgbClr val="775DA0"/>
+                </a:solidFill>
+                <a:effectLst/>
+                <a:latin typeface="ui-sans-serif"/>
+              </a:rPr>
+              <a:t>канал: </a:t>
+            </a:r>
+            <a:r>
+              <a:rPr lang="en-US" sz="1100" b="0" i="0" dirty="0">
+                <a:solidFill>
+                  <a:srgbClr val="AA52DD"/>
+                </a:solidFill>
+                <a:effectLst/>
+                <a:latin typeface="ui-sans-serif"/>
+              </a:rPr>
+              <a:t>t.me/tvhamsters</a:t>
+            </a:r>
+            <a:endParaRPr lang="ru-RU" sz="1100" dirty="0">
+              <a:solidFill>
+                <a:srgbClr val="AA52DD"/>
+              </a:solidFill>
+              <a:latin typeface="ui-sans-serif"/>
+            </a:endParaRPr>
+          </a:p>
+          <a:p>
+            <a:pPr algn="ctr"/>
+            <a:r>
+              <a:rPr lang="ru-RU" sz="1100" b="0" i="0" dirty="0">
+                <a:solidFill>
+                  <a:srgbClr val="775DA0"/>
+                </a:solidFill>
+                <a:effectLst/>
+                <a:latin typeface="ui-sans-serif"/>
+              </a:rPr>
+              <a:t>Бот для связи: </a:t>
+            </a:r>
+            <a:r>
+              <a:rPr lang="en-US" sz="1100" b="0" i="0" dirty="0">
+                <a:solidFill>
+                  <a:srgbClr val="AA52DD"/>
+                </a:solidFill>
+                <a:effectLst/>
+                <a:latin typeface="ui-sans-serif"/>
+              </a:rPr>
+              <a:t>t.me/tvhamsters_bot</a:t>
+            </a:r>
+            <a:r>
+              <a:rPr lang="ru-RU" sz="1100" b="0" i="0" dirty="0">
+                <a:solidFill>
+                  <a:srgbClr val="AA52DD"/>
+                </a:solidFill>
+                <a:effectLst/>
+                <a:latin typeface="ui-sans-serif"/>
+              </a:rPr>
+              <a:t> </a:t>
+            </a:r>
+            <a:endParaRPr lang="ru-RU" sz="1100" dirty="0">
+              <a:solidFill>
+                <a:srgbClr val="AA52DD"/>
+              </a:solidFill>
+            </a:endParaRPr>
+          </a:p>
+        </p:txBody>
+      </p:sp>
+    </p:spTree>
+    <p:extLst>
+      <p:ext uri="{BB962C8B-B14F-4D97-AF65-F5344CB8AC3E}">
+        <p14:creationId xmlns:p14="http://schemas.microsoft.com/office/powerpoint/2010/main" val="2081562730"/>
+      </p:ext>
+    </p:extLst>
+  </p:cSld>
+  <p:clrMapOvr>
+    <a:masterClrMapping/>
+  </p:clrMapOvr>
+</p:sld>
+</file>
+
 <file path=ppt/theme/theme1.xml><?xml version="1.0" encoding="utf-8"?>
 <a:theme xmlns:a="http://schemas.openxmlformats.org/drawingml/2006/main" name="Тема Office">
   <a:themeElements>

</xml_diff>